<commit_message>
Extend benchmark (4 frameworks, up to 5e4 nodes, repetitions); update paper+slides; FPT affiliation; add publishing guide, CITATION.cff, full-benchmark script
</commit_message>
<xml_diff>
--- a/PageRank_Presentation.pptx
+++ b/PageRank_Presentation.pptx
@@ -3038,7 +3038,7 @@
                 <a:ea typeface="Calibri" pitchFamily="34" charset="-122"/>
                 <a:cs typeface="Calibri" pitchFamily="34" charset="-120"/>
               </a:rPr>
-              <a:t>Independent Researcher
+              <a:t>FPT University
 </a:t>
             </a:r>
             <a:pPr indent="0" marL="0">
@@ -3056,7 +3056,7 @@
                 <a:ea typeface="Calibri" pitchFamily="34" charset="-122"/>
                 <a:cs typeface="Calibri" pitchFamily="34" charset="-120"/>
               </a:rPr>
-              <a:t>doanvanhungcuong@gmail.com</a:t>
+              <a:t>cuongdvh25msa13245@fpt.edu.vn</a:t>
             </a:r>
             <a:endParaRPr lang="en-US" sz="1600" dirty="0"/>
           </a:p>
@@ -4839,7 +4839,7 @@
                 <a:ea typeface="Calibri" pitchFamily="34" charset="-122"/>
                 <a:cs typeface="Calibri" pitchFamily="34" charset="-120"/>
               </a:rPr>
-              <a:t>N ∈ {10³, 5×10³, 10⁴}</a:t>
+              <a:t>N ∈ {10³, 5×10³, 10⁴, 5×10⁴} (tới 1.7×10⁵ cạnh)</a:t>
             </a:r>
             <a:endParaRPr lang="en-US" sz="1100" dirty="0"/>
           </a:p>
@@ -5185,7 +5185,7 @@
                 <a:ea typeface="Calibri" pitchFamily="34" charset="-122"/>
                 <a:cs typeface="Calibri" pitchFamily="34" charset="-120"/>
               </a:rPr>
-              <a:t>Container Linux đơn nút (Ubuntu 22.04, x86-64, CPython 3.10) = ảnh CI</a:t>
+              <a:t>Container Linux đơn nút (Ubuntu 22.04, CPython 3.10); mỗi cấu hình chạy 3 lần (mean ± std)</a:t>
             </a:r>
             <a:endParaRPr lang="en-US" sz="1100" dirty="0"/>
           </a:p>
@@ -6549,7 +6549,7 @@
       </p:graphicFrame>
       <p:pic>
         <p:nvPicPr>
-          <p:cNvPr id="5" name="Image 0" descr="accuracy.png">    </p:cNvPr>
+          <p:cNvPr id="5" name="Image 0" descr="newfigs/accuracy.png">    </p:cNvPr>
           <p:cNvPicPr>
             <a:picLocks noChangeAspect="1"/>
           </p:cNvPicPr>
@@ -6819,7 +6819,7 @@
       </p:sp>
       <p:pic>
         <p:nvPicPr>
-          <p:cNvPr id="4" name="Image 0" descr="convergence.png">    </p:cNvPr>
+          <p:cNvPr id="4" name="Image 0" descr="newfigs/convergence.png">    </p:cNvPr>
           <p:cNvPicPr>
             <a:picLocks noChangeAspect="1"/>
           </p:cNvPicPr>
@@ -7510,12 +7510,12 @@
             <a:tbl>
               <a:tblPr/>
               <a:tblGrid>
-                <a:gridCol w="1554480"/>
-                <a:gridCol w="1005840"/>
-                <a:gridCol w="1005840"/>
-                <a:gridCol w="1005840"/>
+                <a:gridCol w="1691640"/>
+                <a:gridCol w="960120"/>
+                <a:gridCol w="960120"/>
+                <a:gridCol w="960120"/>
               </a:tblGrid>
-              <a:tr h="384048">
+              <a:tr h="329184">
                 <a:tc>
                   <a:txBody>
                     <a:bodyPr/>
@@ -7527,7 +7527,7 @@
                       <a:endParaRPr lang="en-US" sz="1050" dirty="0"/>
                     </a:p>
                   </a:txBody>
-                  <a:tcPr marL="50800" marR="50800" marT="25400" marB="25400" anchor="ctr">
+                  <a:tcPr marL="38100" marR="38100" marT="25400" marB="25400" anchor="ctr">
                     <a:lnL w="6350" cap="flat" cmpd="sng" algn="ctr">
                       <a:solidFill>
                         <a:srgbClr val="D7E0EA"/>
@@ -7588,7 +7588,7 @@
                       <a:endParaRPr lang="en-US" sz="1050" dirty="0"/>
                     </a:p>
                   </a:txBody>
-                  <a:tcPr marL="50800" marR="50800" marT="25400" marB="25400" anchor="ctr">
+                  <a:tcPr marL="38100" marR="38100" marT="25400" marB="25400" anchor="ctr">
                     <a:lnL w="6350" cap="flat" cmpd="sng" algn="ctr">
                       <a:solidFill>
                         <a:srgbClr val="D7E0EA"/>
@@ -7649,7 +7649,7 @@
                       <a:endParaRPr lang="en-US" sz="1050" dirty="0"/>
                     </a:p>
                   </a:txBody>
-                  <a:tcPr marL="50800" marR="50800" marT="25400" marB="25400" anchor="ctr">
+                  <a:tcPr marL="38100" marR="38100" marT="25400" marB="25400" anchor="ctr">
                     <a:lnL w="6350" cap="flat" cmpd="sng" algn="ctr">
                       <a:solidFill>
                         <a:srgbClr val="D7E0EA"/>
@@ -7710,7 +7710,7 @@
                       <a:endParaRPr lang="en-US" sz="1050" dirty="0"/>
                     </a:p>
                   </a:txBody>
-                  <a:tcPr marL="50800" marR="50800" marT="25400" marB="25400" anchor="ctr">
+                  <a:tcPr marL="38100" marR="38100" marT="25400" marB="25400" anchor="ctr">
                     <a:lnL w="6350" cap="flat" cmpd="sng" algn="ctr">
                       <a:solidFill>
                         <a:srgbClr val="D7E0EA"/>
@@ -7753,7 +7753,7 @@
                   </a:tcPr>
                 </a:tc>
               </a:tr>
-              <a:tr h="384048">
+              <a:tr h="329184">
                 <a:tc>
                   <a:txBody>
                     <a:bodyPr/>
@@ -7763,7 +7763,7 @@
                         <a:buNone/>
                       </a:pPr>
                       <a:r>
-                        <a:rPr lang="en-US" sz="1050" b="1" dirty="0">
+                        <a:rPr lang="en-US" sz="960" b="1" dirty="0">
                           <a:solidFill>
                             <a:srgbClr val="1E293B"/>
                           </a:solidFill>
@@ -7773,14 +7773,14 @@
                         </a:rPr>
                         <a:t>Core (Python)</a:t>
                       </a:r>
-                      <a:endParaRPr lang="en-US" sz="1050" dirty="0">
+                      <a:endParaRPr lang="en-US" sz="960" dirty="0">
                         <a:latin typeface="Calibri" charset="0"/>
                         <a:ea typeface="Calibri" charset="0"/>
                         <a:cs typeface="Calibri" charset="0"/>
                       </a:endParaRPr>
                     </a:p>
                   </a:txBody>
-                  <a:tcPr marL="50800" marR="50800" marT="25400" marB="25400" anchor="ctr">
+                  <a:tcPr marL="38100" marR="38100" marT="25400" marB="25400" anchor="ctr">
                     <a:lnL w="6350" cap="flat" cmpd="sng" algn="ctr">
                       <a:solidFill>
                         <a:srgbClr val="D7E0EA"/>
@@ -7831,7 +7831,7 @@
                         <a:buNone/>
                       </a:pPr>
                       <a:r>
-                        <a:rPr lang="en-US" sz="1050" dirty="0">
+                        <a:rPr lang="en-US" sz="960" dirty="0">
                           <a:solidFill>
                             <a:srgbClr val="1E293B"/>
                           </a:solidFill>
@@ -7839,16 +7839,16 @@
                           <a:ea typeface="Calibri" pitchFamily="34" charset="-122"/>
                           <a:cs typeface="Calibri" pitchFamily="34" charset="-120"/>
                         </a:rPr>
-                        <a:t>0.12 / 13.4</a:t>
+                        <a:t>0.10 / 13.4</a:t>
                       </a:r>
-                      <a:endParaRPr lang="en-US" sz="1050" dirty="0">
+                      <a:endParaRPr lang="en-US" sz="960" dirty="0">
                         <a:latin typeface="Calibri" charset="0"/>
                         <a:ea typeface="Calibri" charset="0"/>
                         <a:cs typeface="Calibri" charset="0"/>
                       </a:endParaRPr>
                     </a:p>
                   </a:txBody>
-                  <a:tcPr marL="50800" marR="50800" marT="25400" marB="25400" anchor="ctr">
+                  <a:tcPr marL="38100" marR="38100" marT="25400" marB="25400" anchor="ctr">
                     <a:lnL w="6350" cap="flat" cmpd="sng" algn="ctr">
                       <a:solidFill>
                         <a:srgbClr val="D7E0EA"/>
@@ -7899,7 +7899,7 @@
                         <a:buNone/>
                       </a:pPr>
                       <a:r>
-                        <a:rPr lang="en-US" sz="1050" dirty="0">
+                        <a:rPr lang="en-US" sz="960" dirty="0">
                           <a:solidFill>
                             <a:srgbClr val="1E293B"/>
                           </a:solidFill>
@@ -7907,16 +7907,16 @@
                           <a:ea typeface="Calibri" pitchFamily="34" charset="-122"/>
                           <a:cs typeface="Calibri" pitchFamily="34" charset="-120"/>
                         </a:rPr>
-                        <a:t>0.67 / 18.4</a:t>
+                        <a:t>0.30 / 18.4</a:t>
                       </a:r>
-                      <a:endParaRPr lang="en-US" sz="1050" dirty="0">
+                      <a:endParaRPr lang="en-US" sz="960" dirty="0">
                         <a:latin typeface="Calibri" charset="0"/>
                         <a:ea typeface="Calibri" charset="0"/>
                         <a:cs typeface="Calibri" charset="0"/>
                       </a:endParaRPr>
                     </a:p>
                   </a:txBody>
-                  <a:tcPr marL="50800" marR="50800" marT="25400" marB="25400" anchor="ctr">
+                  <a:tcPr marL="38100" marR="38100" marT="25400" marB="25400" anchor="ctr">
                     <a:lnL w="6350" cap="flat" cmpd="sng" algn="ctr">
                       <a:solidFill>
                         <a:srgbClr val="D7E0EA"/>
@@ -7967,7 +7967,7 @@
                         <a:buNone/>
                       </a:pPr>
                       <a:r>
-                        <a:rPr lang="en-US" sz="1050" dirty="0">
+                        <a:rPr lang="en-US" sz="960" dirty="0">
                           <a:solidFill>
                             <a:srgbClr val="1E293B"/>
                           </a:solidFill>
@@ -7975,16 +7975,16 @@
                           <a:ea typeface="Calibri" pitchFamily="34" charset="-122"/>
                           <a:cs typeface="Calibri" pitchFamily="34" charset="-120"/>
                         </a:rPr>
-                        <a:t>0.87 / 24.6</a:t>
+                        <a:t>0.65 / 24.6</a:t>
                       </a:r>
-                      <a:endParaRPr lang="en-US" sz="1050" dirty="0">
+                      <a:endParaRPr lang="en-US" sz="960" dirty="0">
                         <a:latin typeface="Calibri" charset="0"/>
                         <a:ea typeface="Calibri" charset="0"/>
                         <a:cs typeface="Calibri" charset="0"/>
                       </a:endParaRPr>
                     </a:p>
                   </a:txBody>
-                  <a:tcPr marL="50800" marR="50800" marT="25400" marB="25400" anchor="ctr">
+                  <a:tcPr marL="38100" marR="38100" marT="25400" marB="25400" anchor="ctr">
                     <a:lnL w="6350" cap="flat" cmpd="sng" algn="ctr">
                       <a:solidFill>
                         <a:srgbClr val="D7E0EA"/>
@@ -8027,7 +8027,7 @@
                   </a:tcPr>
                 </a:tc>
               </a:tr>
-              <a:tr h="384048">
+              <a:tr h="329184">
                 <a:tc>
                   <a:txBody>
                     <a:bodyPr/>
@@ -8037,7 +8037,7 @@
                         <a:buNone/>
                       </a:pPr>
                       <a:r>
-                        <a:rPr lang="en-US" sz="1050" b="1" dirty="0">
+                        <a:rPr lang="en-US" sz="960" b="1" dirty="0">
                           <a:solidFill>
                             <a:srgbClr val="1E293B"/>
                           </a:solidFill>
@@ -8047,14 +8047,14 @@
                         </a:rPr>
                         <a:t>mrjob (core)</a:t>
                       </a:r>
-                      <a:endParaRPr lang="en-US" sz="1050" dirty="0">
+                      <a:endParaRPr lang="en-US" sz="960" dirty="0">
                         <a:latin typeface="Calibri" charset="0"/>
                         <a:ea typeface="Calibri" charset="0"/>
                         <a:cs typeface="Calibri" charset="0"/>
                       </a:endParaRPr>
                     </a:p>
                   </a:txBody>
-                  <a:tcPr marL="50800" marR="50800" marT="25400" marB="25400" anchor="ctr">
+                  <a:tcPr marL="38100" marR="38100" marT="25400" marB="25400" anchor="ctr">
                     <a:lnL w="6350" cap="flat" cmpd="sng" algn="ctr">
                       <a:solidFill>
                         <a:srgbClr val="D7E0EA"/>
@@ -8105,7 +8105,7 @@
                         <a:buNone/>
                       </a:pPr>
                       <a:r>
-                        <a:rPr lang="en-US" sz="1050" dirty="0">
+                        <a:rPr lang="en-US" sz="960" dirty="0">
                           <a:solidFill>
                             <a:srgbClr val="1E293B"/>
                           </a:solidFill>
@@ -8113,16 +8113,16 @@
                           <a:ea typeface="Calibri" pitchFamily="34" charset="-122"/>
                           <a:cs typeface="Calibri" pitchFamily="34" charset="-120"/>
                         </a:rPr>
-                        <a:t>0.21 / 24.5</a:t>
+                        <a:t>0.17 / 24.2</a:t>
                       </a:r>
-                      <a:endParaRPr lang="en-US" sz="1050" dirty="0">
+                      <a:endParaRPr lang="en-US" sz="960" dirty="0">
                         <a:latin typeface="Calibri" charset="0"/>
                         <a:ea typeface="Calibri" charset="0"/>
                         <a:cs typeface="Calibri" charset="0"/>
                       </a:endParaRPr>
                     </a:p>
                   </a:txBody>
-                  <a:tcPr marL="50800" marR="50800" marT="25400" marB="25400" anchor="ctr">
+                  <a:tcPr marL="38100" marR="38100" marT="25400" marB="25400" anchor="ctr">
                     <a:lnL w="6350" cap="flat" cmpd="sng" algn="ctr">
                       <a:solidFill>
                         <a:srgbClr val="D7E0EA"/>
@@ -8173,7 +8173,7 @@
                         <a:buNone/>
                       </a:pPr>
                       <a:r>
-                        <a:rPr lang="en-US" sz="1050" dirty="0">
+                        <a:rPr lang="en-US" sz="960" dirty="0">
                           <a:solidFill>
                             <a:srgbClr val="1E293B"/>
                           </a:solidFill>
@@ -8181,16 +8181,16 @@
                           <a:ea typeface="Calibri" pitchFamily="34" charset="-122"/>
                           <a:cs typeface="Calibri" pitchFamily="34" charset="-120"/>
                         </a:rPr>
-                        <a:t>1.05 / 29.2</a:t>
+                        <a:t>0.44 / 29.3</a:t>
                       </a:r>
-                      <a:endParaRPr lang="en-US" sz="1050" dirty="0">
+                      <a:endParaRPr lang="en-US" sz="960" dirty="0">
                         <a:latin typeface="Calibri" charset="0"/>
                         <a:ea typeface="Calibri" charset="0"/>
                         <a:cs typeface="Calibri" charset="0"/>
                       </a:endParaRPr>
                     </a:p>
                   </a:txBody>
-                  <a:tcPr marL="50800" marR="50800" marT="25400" marB="25400" anchor="ctr">
+                  <a:tcPr marL="38100" marR="38100" marT="25400" marB="25400" anchor="ctr">
                     <a:lnL w="6350" cap="flat" cmpd="sng" algn="ctr">
                       <a:solidFill>
                         <a:srgbClr val="D7E0EA"/>
@@ -8241,7 +8241,7 @@
                         <a:buNone/>
                       </a:pPr>
                       <a:r>
-                        <a:rPr lang="en-US" sz="1050" dirty="0">
+                        <a:rPr lang="en-US" sz="960" dirty="0">
                           <a:solidFill>
                             <a:srgbClr val="1E293B"/>
                           </a:solidFill>
@@ -8249,16 +8249,16 @@
                           <a:ea typeface="Calibri" pitchFamily="34" charset="-122"/>
                           <a:cs typeface="Calibri" pitchFamily="34" charset="-120"/>
                         </a:rPr>
-                        <a:t>1.14 / 35.5</a:t>
+                        <a:t>0.71 / 35.4</a:t>
                       </a:r>
-                      <a:endParaRPr lang="en-US" sz="1050" dirty="0">
+                      <a:endParaRPr lang="en-US" sz="960" dirty="0">
                         <a:latin typeface="Calibri" charset="0"/>
                         <a:ea typeface="Calibri" charset="0"/>
                         <a:cs typeface="Calibri" charset="0"/>
                       </a:endParaRPr>
                     </a:p>
                   </a:txBody>
-                  <a:tcPr marL="50800" marR="50800" marT="25400" marB="25400" anchor="ctr">
+                  <a:tcPr marL="38100" marR="38100" marT="25400" marB="25400" anchor="ctr">
                     <a:lnL w="6350" cap="flat" cmpd="sng" algn="ctr">
                       <a:solidFill>
                         <a:srgbClr val="D7E0EA"/>
@@ -8301,7 +8301,7 @@
                   </a:tcPr>
                 </a:tc>
               </a:tr>
-              <a:tr h="384048">
+              <a:tr h="329184">
                 <a:tc>
                   <a:txBody>
                     <a:bodyPr/>
@@ -8311,7 +8311,7 @@
                         <a:buNone/>
                       </a:pPr>
                       <a:r>
-                        <a:rPr lang="en-US" sz="1050" b="1" dirty="0">
+                        <a:rPr lang="en-US" sz="960" b="1" dirty="0">
                           <a:solidFill>
                             <a:srgbClr val="1E293B"/>
                           </a:solidFill>
@@ -8319,16 +8319,16 @@
                           <a:ea typeface="Calibri" pitchFamily="34" charset="-122"/>
                           <a:cs typeface="Calibri" pitchFamily="34" charset="-120"/>
                         </a:rPr>
-                        <a:t>Hadoop Streaming</a:t>
+                        <a:t>mrjob (MapReduce)</a:t>
                       </a:r>
-                      <a:endParaRPr lang="en-US" sz="1050" dirty="0">
+                      <a:endParaRPr lang="en-US" sz="960" dirty="0">
                         <a:latin typeface="Calibri" charset="0"/>
                         <a:ea typeface="Calibri" charset="0"/>
                         <a:cs typeface="Calibri" charset="0"/>
                       </a:endParaRPr>
                     </a:p>
                   </a:txBody>
-                  <a:tcPr marL="50800" marR="50800" marT="25400" marB="25400" anchor="ctr">
+                  <a:tcPr marL="38100" marR="38100" marT="25400" marB="25400" anchor="ctr">
                     <a:lnL w="6350" cap="flat" cmpd="sng" algn="ctr">
                       <a:solidFill>
                         <a:srgbClr val="D7E0EA"/>
@@ -8379,7 +8379,7 @@
                         <a:buNone/>
                       </a:pPr>
                       <a:r>
-                        <a:rPr lang="en-US" sz="1050" dirty="0">
+                        <a:rPr lang="en-US" sz="960" dirty="0">
                           <a:solidFill>
                             <a:srgbClr val="1E293B"/>
                           </a:solidFill>
@@ -8387,16 +8387,16 @@
                           <a:ea typeface="Calibri" pitchFamily="34" charset="-122"/>
                           <a:cs typeface="Calibri" pitchFamily="34" charset="-120"/>
                         </a:rPr>
-                        <a:t>1.57 / 9.6</a:t>
+                        <a:t>4.89 / 29.7</a:t>
                       </a:r>
-                      <a:endParaRPr lang="en-US" sz="1050" dirty="0">
+                      <a:endParaRPr lang="en-US" sz="960" dirty="0">
                         <a:latin typeface="Calibri" charset="0"/>
                         <a:ea typeface="Calibri" charset="0"/>
                         <a:cs typeface="Calibri" charset="0"/>
                       </a:endParaRPr>
                     </a:p>
                   </a:txBody>
-                  <a:tcPr marL="50800" marR="50800" marT="25400" marB="25400" anchor="ctr">
+                  <a:tcPr marL="38100" marR="38100" marT="25400" marB="25400" anchor="ctr">
                     <a:lnL w="6350" cap="flat" cmpd="sng" algn="ctr">
                       <a:solidFill>
                         <a:srgbClr val="D7E0EA"/>
@@ -8447,7 +8447,7 @@
                         <a:buNone/>
                       </a:pPr>
                       <a:r>
-                        <a:rPr lang="en-US" sz="1050" dirty="0">
+                        <a:rPr lang="en-US" sz="960" dirty="0">
                           <a:solidFill>
                             <a:srgbClr val="1E293B"/>
                           </a:solidFill>
@@ -8455,16 +8455,16 @@
                           <a:ea typeface="Calibri" pitchFamily="34" charset="-122"/>
                           <a:cs typeface="Calibri" pitchFamily="34" charset="-120"/>
                         </a:rPr>
-                        <a:t>3.41 / 11.6</a:t>
+                        <a:t>13.26 / 39.9</a:t>
                       </a:r>
-                      <a:endParaRPr lang="en-US" sz="1050" dirty="0">
+                      <a:endParaRPr lang="en-US" sz="960" dirty="0">
                         <a:latin typeface="Calibri" charset="0"/>
                         <a:ea typeface="Calibri" charset="0"/>
                         <a:cs typeface="Calibri" charset="0"/>
                       </a:endParaRPr>
                     </a:p>
                   </a:txBody>
-                  <a:tcPr marL="50800" marR="50800" marT="25400" marB="25400" anchor="ctr">
+                  <a:tcPr marL="38100" marR="38100" marT="25400" marB="25400" anchor="ctr">
                     <a:lnL w="6350" cap="flat" cmpd="sng" algn="ctr">
                       <a:solidFill>
                         <a:srgbClr val="D7E0EA"/>
@@ -8515,7 +8515,7 @@
                         <a:buNone/>
                       </a:pPr>
                       <a:r>
-                        <a:rPr lang="en-US" sz="1050" dirty="0">
+                        <a:rPr lang="en-US" sz="960" dirty="0">
                           <a:solidFill>
                             <a:srgbClr val="1E293B"/>
                           </a:solidFill>
@@ -8523,16 +8523,16 @@
                           <a:ea typeface="Calibri" pitchFamily="34" charset="-122"/>
                           <a:cs typeface="Calibri" pitchFamily="34" charset="-120"/>
                         </a:rPr>
-                        <a:t>7.56 / 13.9</a:t>
+                        <a:t>28.32 / 52.0</a:t>
                       </a:r>
-                      <a:endParaRPr lang="en-US" sz="1050" dirty="0">
+                      <a:endParaRPr lang="en-US" sz="960" dirty="0">
                         <a:latin typeface="Calibri" charset="0"/>
                         <a:ea typeface="Calibri" charset="0"/>
                         <a:cs typeface="Calibri" charset="0"/>
                       </a:endParaRPr>
                     </a:p>
                   </a:txBody>
-                  <a:tcPr marL="50800" marR="50800" marT="25400" marB="25400" anchor="ctr">
+                  <a:tcPr marL="38100" marR="38100" marT="25400" marB="25400" anchor="ctr">
                     <a:lnL w="6350" cap="flat" cmpd="sng" algn="ctr">
                       <a:solidFill>
                         <a:srgbClr val="D7E0EA"/>
@@ -8571,6 +8571,280 @@
                     </a:lnB>
                     <a:solidFill>
                       <a:srgbClr val="FFFFFF"/>
+                    </a:solidFill>
+                  </a:tcPr>
+                </a:tc>
+              </a:tr>
+              <a:tr h="329184">
+                <a:tc>
+                  <a:txBody>
+                    <a:bodyPr/>
+                    <a:lstStyle/>
+                    <a:p>
+                      <a:pPr algn="l" indent="0" marL="0">
+                        <a:buNone/>
+                      </a:pPr>
+                      <a:r>
+                        <a:rPr lang="en-US" sz="960" b="1" dirty="0">
+                          <a:solidFill>
+                            <a:srgbClr val="1E293B"/>
+                          </a:solidFill>
+                          <a:latin typeface="Calibri" pitchFamily="34" charset="0"/>
+                          <a:ea typeface="Calibri" pitchFamily="34" charset="-122"/>
+                          <a:cs typeface="Calibri" pitchFamily="34" charset="-120"/>
+                        </a:rPr>
+                        <a:t>Hadoop Streaming</a:t>
+                      </a:r>
+                      <a:endParaRPr lang="en-US" sz="960" dirty="0">
+                        <a:latin typeface="Calibri" charset="0"/>
+                        <a:ea typeface="Calibri" charset="0"/>
+                        <a:cs typeface="Calibri" charset="0"/>
+                      </a:endParaRPr>
+                    </a:p>
+                  </a:txBody>
+                  <a:tcPr marL="38100" marR="38100" marT="25400" marB="25400" anchor="ctr">
+                    <a:lnL w="6350" cap="flat" cmpd="sng" algn="ctr">
+                      <a:solidFill>
+                        <a:srgbClr val="D7E0EA"/>
+                      </a:solidFill>
+                      <a:prstDash val="solid"/>
+                      <a:round/>
+                      <a:headEnd type="none" w="med" len="med"/>
+                      <a:tailEnd type="none" w="med" len="med"/>
+                    </a:lnL>
+                    <a:lnR w="6350" cap="flat" cmpd="sng" algn="ctr">
+                      <a:solidFill>
+                        <a:srgbClr val="D7E0EA"/>
+                      </a:solidFill>
+                      <a:prstDash val="solid"/>
+                      <a:round/>
+                      <a:headEnd type="none" w="med" len="med"/>
+                      <a:tailEnd type="none" w="med" len="med"/>
+                    </a:lnR>
+                    <a:lnT w="6350" cap="flat" cmpd="sng" algn="ctr">
+                      <a:solidFill>
+                        <a:srgbClr val="D7E0EA"/>
+                      </a:solidFill>
+                      <a:prstDash val="solid"/>
+                      <a:round/>
+                      <a:headEnd type="none" w="med" len="med"/>
+                      <a:tailEnd type="none" w="med" len="med"/>
+                    </a:lnT>
+                    <a:lnB w="6350" cap="flat" cmpd="sng" algn="ctr">
+                      <a:solidFill>
+                        <a:srgbClr val="D7E0EA"/>
+                      </a:solidFill>
+                      <a:prstDash val="solid"/>
+                      <a:round/>
+                      <a:headEnd type="none" w="med" len="med"/>
+                      <a:tailEnd type="none" w="med" len="med"/>
+                    </a:lnB>
+                    <a:solidFill>
+                      <a:srgbClr val="F2F6FA"/>
+                    </a:solidFill>
+                  </a:tcPr>
+                </a:tc>
+                <a:tc>
+                  <a:txBody>
+                    <a:bodyPr/>
+                    <a:lstStyle/>
+                    <a:p>
+                      <a:pPr algn="ctr" indent="0" marL="0">
+                        <a:buNone/>
+                      </a:pPr>
+                      <a:r>
+                        <a:rPr lang="en-US" sz="960" dirty="0">
+                          <a:solidFill>
+                            <a:srgbClr val="1E293B"/>
+                          </a:solidFill>
+                          <a:latin typeface="Calibri" pitchFamily="34" charset="0"/>
+                          <a:ea typeface="Calibri" pitchFamily="34" charset="-122"/>
+                          <a:cs typeface="Calibri" pitchFamily="34" charset="-120"/>
+                        </a:rPr>
+                        <a:t>1.36 / 9.5</a:t>
+                      </a:r>
+                      <a:endParaRPr lang="en-US" sz="960" dirty="0">
+                        <a:latin typeface="Calibri" charset="0"/>
+                        <a:ea typeface="Calibri" charset="0"/>
+                        <a:cs typeface="Calibri" charset="0"/>
+                      </a:endParaRPr>
+                    </a:p>
+                  </a:txBody>
+                  <a:tcPr marL="38100" marR="38100" marT="25400" marB="25400" anchor="ctr">
+                    <a:lnL w="6350" cap="flat" cmpd="sng" algn="ctr">
+                      <a:solidFill>
+                        <a:srgbClr val="D7E0EA"/>
+                      </a:solidFill>
+                      <a:prstDash val="solid"/>
+                      <a:round/>
+                      <a:headEnd type="none" w="med" len="med"/>
+                      <a:tailEnd type="none" w="med" len="med"/>
+                    </a:lnL>
+                    <a:lnR w="6350" cap="flat" cmpd="sng" algn="ctr">
+                      <a:solidFill>
+                        <a:srgbClr val="D7E0EA"/>
+                      </a:solidFill>
+                      <a:prstDash val="solid"/>
+                      <a:round/>
+                      <a:headEnd type="none" w="med" len="med"/>
+                      <a:tailEnd type="none" w="med" len="med"/>
+                    </a:lnR>
+                    <a:lnT w="6350" cap="flat" cmpd="sng" algn="ctr">
+                      <a:solidFill>
+                        <a:srgbClr val="D7E0EA"/>
+                      </a:solidFill>
+                      <a:prstDash val="solid"/>
+                      <a:round/>
+                      <a:headEnd type="none" w="med" len="med"/>
+                      <a:tailEnd type="none" w="med" len="med"/>
+                    </a:lnT>
+                    <a:lnB w="6350" cap="flat" cmpd="sng" algn="ctr">
+                      <a:solidFill>
+                        <a:srgbClr val="D7E0EA"/>
+                      </a:solidFill>
+                      <a:prstDash val="solid"/>
+                      <a:round/>
+                      <a:headEnd type="none" w="med" len="med"/>
+                      <a:tailEnd type="none" w="med" len="med"/>
+                    </a:lnB>
+                    <a:solidFill>
+                      <a:srgbClr val="F2F6FA"/>
+                    </a:solidFill>
+                  </a:tcPr>
+                </a:tc>
+                <a:tc>
+                  <a:txBody>
+                    <a:bodyPr/>
+                    <a:lstStyle/>
+                    <a:p>
+                      <a:pPr algn="ctr" indent="0" marL="0">
+                        <a:buNone/>
+                      </a:pPr>
+                      <a:r>
+                        <a:rPr lang="en-US" sz="960" dirty="0">
+                          <a:solidFill>
+                            <a:srgbClr val="1E293B"/>
+                          </a:solidFill>
+                          <a:latin typeface="Calibri" pitchFamily="34" charset="0"/>
+                          <a:ea typeface="Calibri" pitchFamily="34" charset="-122"/>
+                          <a:cs typeface="Calibri" pitchFamily="34" charset="-120"/>
+                        </a:rPr>
+                        <a:t>2.98 / 11.7</a:t>
+                      </a:r>
+                      <a:endParaRPr lang="en-US" sz="960" dirty="0">
+                        <a:latin typeface="Calibri" charset="0"/>
+                        <a:ea typeface="Calibri" charset="0"/>
+                        <a:cs typeface="Calibri" charset="0"/>
+                      </a:endParaRPr>
+                    </a:p>
+                  </a:txBody>
+                  <a:tcPr marL="38100" marR="38100" marT="25400" marB="25400" anchor="ctr">
+                    <a:lnL w="6350" cap="flat" cmpd="sng" algn="ctr">
+                      <a:solidFill>
+                        <a:srgbClr val="D7E0EA"/>
+                      </a:solidFill>
+                      <a:prstDash val="solid"/>
+                      <a:round/>
+                      <a:headEnd type="none" w="med" len="med"/>
+                      <a:tailEnd type="none" w="med" len="med"/>
+                    </a:lnL>
+                    <a:lnR w="6350" cap="flat" cmpd="sng" algn="ctr">
+                      <a:solidFill>
+                        <a:srgbClr val="D7E0EA"/>
+                      </a:solidFill>
+                      <a:prstDash val="solid"/>
+                      <a:round/>
+                      <a:headEnd type="none" w="med" len="med"/>
+                      <a:tailEnd type="none" w="med" len="med"/>
+                    </a:lnR>
+                    <a:lnT w="6350" cap="flat" cmpd="sng" algn="ctr">
+                      <a:solidFill>
+                        <a:srgbClr val="D7E0EA"/>
+                      </a:solidFill>
+                      <a:prstDash val="solid"/>
+                      <a:round/>
+                      <a:headEnd type="none" w="med" len="med"/>
+                      <a:tailEnd type="none" w="med" len="med"/>
+                    </a:lnT>
+                    <a:lnB w="6350" cap="flat" cmpd="sng" algn="ctr">
+                      <a:solidFill>
+                        <a:srgbClr val="D7E0EA"/>
+                      </a:solidFill>
+                      <a:prstDash val="solid"/>
+                      <a:round/>
+                      <a:headEnd type="none" w="med" len="med"/>
+                      <a:tailEnd type="none" w="med" len="med"/>
+                    </a:lnB>
+                    <a:solidFill>
+                      <a:srgbClr val="F2F6FA"/>
+                    </a:solidFill>
+                  </a:tcPr>
+                </a:tc>
+                <a:tc>
+                  <a:txBody>
+                    <a:bodyPr/>
+                    <a:lstStyle/>
+                    <a:p>
+                      <a:pPr algn="ctr" indent="0" marL="0">
+                        <a:buNone/>
+                      </a:pPr>
+                      <a:r>
+                        <a:rPr lang="en-US" sz="960" dirty="0">
+                          <a:solidFill>
+                            <a:srgbClr val="1E293B"/>
+                          </a:solidFill>
+                          <a:latin typeface="Calibri" pitchFamily="34" charset="0"/>
+                          <a:ea typeface="Calibri" pitchFamily="34" charset="-122"/>
+                          <a:cs typeface="Calibri" pitchFamily="34" charset="-120"/>
+                        </a:rPr>
+                        <a:t>4.98 / 13.8</a:t>
+                      </a:r>
+                      <a:endParaRPr lang="en-US" sz="960" dirty="0">
+                        <a:latin typeface="Calibri" charset="0"/>
+                        <a:ea typeface="Calibri" charset="0"/>
+                        <a:cs typeface="Calibri" charset="0"/>
+                      </a:endParaRPr>
+                    </a:p>
+                  </a:txBody>
+                  <a:tcPr marL="38100" marR="38100" marT="25400" marB="25400" anchor="ctr">
+                    <a:lnL w="6350" cap="flat" cmpd="sng" algn="ctr">
+                      <a:solidFill>
+                        <a:srgbClr val="D7E0EA"/>
+                      </a:solidFill>
+                      <a:prstDash val="solid"/>
+                      <a:round/>
+                      <a:headEnd type="none" w="med" len="med"/>
+                      <a:tailEnd type="none" w="med" len="med"/>
+                    </a:lnL>
+                    <a:lnR w="6350" cap="flat" cmpd="sng" algn="ctr">
+                      <a:solidFill>
+                        <a:srgbClr val="D7E0EA"/>
+                      </a:solidFill>
+                      <a:prstDash val="solid"/>
+                      <a:round/>
+                      <a:headEnd type="none" w="med" len="med"/>
+                      <a:tailEnd type="none" w="med" len="med"/>
+                    </a:lnR>
+                    <a:lnT w="6350" cap="flat" cmpd="sng" algn="ctr">
+                      <a:solidFill>
+                        <a:srgbClr val="D7E0EA"/>
+                      </a:solidFill>
+                      <a:prstDash val="solid"/>
+                      <a:round/>
+                      <a:headEnd type="none" w="med" len="med"/>
+                      <a:tailEnd type="none" w="med" len="med"/>
+                    </a:lnT>
+                    <a:lnB w="6350" cap="flat" cmpd="sng" algn="ctr">
+                      <a:solidFill>
+                        <a:srgbClr val="D7E0EA"/>
+                      </a:solidFill>
+                      <a:prstDash val="solid"/>
+                      <a:round/>
+                      <a:headEnd type="none" w="med" len="med"/>
+                      <a:tailEnd type="none" w="med" len="med"/>
+                    </a:lnB>
+                    <a:solidFill>
+                      <a:srgbClr val="F2F6FA"/>
                     </a:solidFill>
                   </a:tcPr>
                 </a:tc>
@@ -8587,8 +8861,8 @@
         </p:nvSpPr>
         <p:spPr>
           <a:xfrm>
-            <a:off x="502920" y="3200400"/>
-            <a:ext cx="4572000" cy="274320"/>
+            <a:off x="502920" y="3520440"/>
+            <a:ext cx="4572000" cy="292608"/>
           </a:xfrm>
           <a:prstGeom prst="rect">
             <a:avLst/>
@@ -8604,7 +8878,7 @@
               <a:buNone/>
             </a:pPr>
             <a:r>
-              <a:rPr lang="en-US" sz="1000" i="1" dirty="0">
+              <a:rPr lang="en-US" sz="950" i="1" dirty="0">
                 <a:solidFill>
                   <a:srgbClr val="5B6B7B"/>
                 </a:solidFill>
@@ -8612,9 +8886,9 @@
                 <a:ea typeface="Calibri" pitchFamily="34" charset="-122"/>
                 <a:cs typeface="Calibri" pitchFamily="34" charset="-120"/>
               </a:rPr>
-              <a:t>Mỗi ô = thời gian (s) / bộ nhớ đỉnh (MB)</a:t>
-            </a:r>
-            <a:endParaRPr lang="en-US" sz="1000" dirty="0"/>
+              <a:t>Mỗi ô = thời gian (s) / bộ nhớ đỉnh (MB); engine in-memory mở rộng tới 5×10⁴ nút</a:t>
+            </a:r>
+            <a:endParaRPr lang="en-US" sz="950" dirty="0"/>
           </a:p>
         </p:txBody>
       </p:sp>
@@ -8626,8 +8900,8 @@
         </p:nvSpPr>
         <p:spPr>
           <a:xfrm>
-            <a:off x="502920" y="3520440"/>
-            <a:ext cx="4572000" cy="1097280"/>
+            <a:off x="502920" y="3840480"/>
+            <a:ext cx="4572000" cy="868680"/>
           </a:xfrm>
           <a:prstGeom prst="rect">
             <a:avLst/>
@@ -8641,12 +8915,12 @@
           <a:p>
             <a:pPr indent="0" marL="0">
               <a:lnSpc>
-                <a:spcPct val="103000"/>
+                <a:spcPct val="102000"/>
               </a:lnSpc>
               <a:buNone/>
             </a:pPr>
             <a:r>
-              <a:rPr lang="en-US" sz="1130" b="1" dirty="0">
+              <a:rPr lang="en-US" sz="1100" b="1" dirty="0">
                 <a:solidFill>
                   <a:srgbClr val="102A43"/>
                 </a:solidFill>
@@ -8654,16 +8928,16 @@
                 <a:ea typeface="Calibri" pitchFamily="34" charset="-122"/>
                 <a:cs typeface="Calibri" pitchFamily="34" charset="-120"/>
               </a:rPr>
-              <a:t>Engine in-memory nhanh nhất ở mọi cỡ. </a:t>
+              <a:t>Engine in-memory nhanh nhất. </a:t>
             </a:r>
             <a:pPr indent="0" marL="0">
               <a:lnSpc>
-                <a:spcPct val="103000"/>
+                <a:spcPct val="102000"/>
               </a:lnSpc>
               <a:buNone/>
             </a:pPr>
             <a:r>
-              <a:rPr lang="en-US" sz="1130" dirty="0">
+              <a:rPr lang="en-US" sz="1100" dirty="0">
                 <a:solidFill>
                   <a:srgbClr val="1E293B"/>
                 </a:solidFill>
@@ -8671,15 +8945,15 @@
                 <a:ea typeface="Calibri" pitchFamily="34" charset="-122"/>
                 <a:cs typeface="Calibri" pitchFamily="34" charset="-120"/>
               </a:rPr>
-              <a:t>mrjob thêm overhead khiêm tốn (1.3–1.8×); Hadoop Streaming chậm hơn ~5–13× do tạo tiến trình &amp; tuần tự hóa lại toàn bộ trạng thái mỗi vòng.</a:t>
-            </a:r>
-            <a:endParaRPr lang="en-US" sz="1130" dirty="0"/>
+              <a:t>mrjob-core overhead giảm dần (1.7×→≈1×); Hadoop Streaming chậm ~8–14×; bản mrjob MapReduce thật chậm ~44–49× vì spawn một job mới mỗi vòng lặp.</a:t>
+            </a:r>
+            <a:endParaRPr lang="en-US" sz="1100" dirty="0"/>
           </a:p>
         </p:txBody>
       </p:sp>
       <p:pic>
         <p:nvPicPr>
-          <p:cNvPr id="7" name="Image 0" descr="runtime_scaling.png">    </p:cNvPr>
+          <p:cNvPr id="7" name="Image 0" descr="newfigs/runtime_scaling.png">    </p:cNvPr>
           <p:cNvPicPr>
             <a:picLocks noChangeAspect="1"/>
           </p:cNvPicPr>
@@ -8890,7 +9164,7 @@
       </p:sp>
       <p:pic>
         <p:nvPicPr>
-          <p:cNvPr id="4" name="Image 0" descr="speedup.png">    </p:cNvPr>
+          <p:cNvPr id="4" name="Image 0" descr="newfigs/speedup.png">    </p:cNvPr>
           <p:cNvPicPr>
             <a:picLocks noChangeAspect="1"/>
           </p:cNvPicPr>
@@ -8913,7 +9187,7 @@
       </p:pic>
       <p:pic>
         <p:nvPicPr>
-          <p:cNvPr id="5" name="Image 1" descr="memory_scaling.png">    </p:cNvPr>
+          <p:cNvPr id="5" name="Image 1" descr="newfigs/memory_scaling.png">    </p:cNvPr>
           <p:cNvPicPr>
             <a:picLocks noChangeAspect="1"/>
           </p:cNvPicPr>
@@ -12539,7 +12813,7 @@
                 <a:ea typeface="Calibri" pitchFamily="34" charset="-122"/>
                 <a:cs typeface="Calibri" pitchFamily="34" charset="-120"/>
               </a:rPr>
-              <a:t>Doan Van Hung Cuong · doanvanhungcuong@gmail.com</a:t>
+              <a:t>Doan Van Hung Cuong · cuongdvh25msa13245@fpt.edu.vn</a:t>
             </a:r>
             <a:endParaRPr lang="en-US" sz="1600" dirty="0"/>
           </a:p>

</xml_diff>